<commit_message>
codex update v1 finish
</commit_message>
<xml_diff>
--- a/ppt-generation-enterprise/workspace/某零售品牌现场 Demo-会员生命周期运营增长与流失预警闭环/某零售品牌现场 Demo-会员生命周期运营增长与流失预警闭环方案.pptx
+++ b/ppt-generation-enterprise/workspace/某零售品牌现场 Demo-会员生命周期运营增长与流失预警闭环/某零售品牌现场 Demo-会员生命周期运营增长与流失预警闭环方案.pptx
@@ -516,7 +516,7 @@
           </a:p>
           <a:p>
             <a:r>
-              <a:t>- 该场景聚焦会员运营负责人最关心的三段链路：重点客群识别、营销内容落地和流失干预。先通过一个统一工作台把洞察、生成、复盘和保留动作串起来，可以较快验证 AI 对会员增长与留存的业务价值。</a:t>
+              <a:t>- 该场景聚焦会员运营负责人最关心的三段能力：识别重点客群、加速内容与活动落地、提前发现并干预流失风险。以工作台方式承载 AI Flow，能够在较短周期内直观看到增长效率与客户保留的联动价值。</a:t>
             </a:r>
           </a:p>
         </p:txBody>
@@ -871,7 +871,7 @@
           </a:p>
           <a:p>
             <a:r>
-              <a:t>- 该场景聚焦会员运营负责人最关心的三段链路：重点客群识别、营销内容落地和流失干预。先通过一个统一工作台把洞察、生成、复盘和保留动作串起来，可以较快验证 AI 对会员增长与留存的业务价值。</a:t>
+              <a:t>- 该场景聚焦会员运营负责人最关心的三段能力：识别重点客群、加速内容与活动落地、提前发现并干预流失风险。以工作台方式承载 AI Flow，能够在较短周期内直观看到增长效率与客户保留的联动价值。</a:t>
             </a:r>
           </a:p>
         </p:txBody>
@@ -4606,7 +4606,7 @@
                 </a:solidFill>
                 <a:latin typeface="Microsoft YaHei"/>
               </a:rPr>
-              <a:t>让会员运营团队从多系统切换和人工拼装，转向在一个工作台里完成洞察、生成、复盘和干预。</a:t>
+              <a:t>让会员运营团队从多系统切换和人工拼装，转向在一个工作台里完成洞察、生成、复盘和保留联动。</a:t>
             </a:r>
           </a:p>
         </p:txBody>
@@ -5130,7 +5130,7 @@
                 </a:solidFill>
                 <a:latin typeface="Microsoft YaHei"/>
               </a:rPr>
-              <a:t>优先验证会员洞察、营销内容生成、活动复盘和流失预警四段闭环</a:t>
+              <a:t>优先验证会员洞察、内容生成、活动复盘和流失预警四段闭环</a:t>
             </a:r>
           </a:p>
         </p:txBody>
@@ -5303,7 +5303,7 @@
                 </a:solidFill>
                 <a:latin typeface="Microsoft YaHei"/>
               </a:rPr>
-              <a:t>数据与数字化团队</a:t>
+              <a:t>数据 / 数字化团队</a:t>
             </a:r>
           </a:p>
         </p:txBody>
@@ -5428,7 +5428,7 @@
                 </a:solidFill>
                 <a:latin typeface="Microsoft YaHei"/>
               </a:rPr>
-              <a:t>1. 确认一个重点会员客群和一类核心营销活动作为试点</a:t>
+              <a:t>1. 确认一个重点会员客群和一类典型活动作为试点</a:t>
             </a:r>
           </a:p>
           <a:p>
@@ -5444,7 +5444,7 @@
                 </a:solidFill>
                 <a:latin typeface="Microsoft YaHei"/>
               </a:rPr>
-              <a:t>2. 准备会员画像、历史活动结果和流失样本数据</a:t>
+              <a:t>2. 准备会员画像、活动结果和高流失会员样本数据</a:t>
             </a:r>
           </a:p>
           <a:p>
@@ -5460,7 +5460,7 @@
                 </a:solidFill>
                 <a:latin typeface="Microsoft YaHei"/>
               </a:rPr>
-              <a:t>3. 两周内完成工作台演示原型与验证口径</a:t>
+              <a:t>3. 两周内完成工作台原型与验证口径</a:t>
             </a:r>
           </a:p>
         </p:txBody>
@@ -5760,7 +5760,7 @@
                 </a:solidFill>
                 <a:latin typeface="Microsoft YaHei"/>
               </a:rPr>
-              <a:t>1. 运营团队汇总会员画像、历史活动结果和渠道反馈，人工识别重点客群</a:t>
+              <a:t>1. 运营团队汇总会员画像、历史活动结果和渠道反馈，识别重点客群与运营机会</a:t>
             </a:r>
           </a:p>
           <a:p>
@@ -5776,7 +5776,7 @@
                 </a:solidFill>
                 <a:latin typeface="Microsoft YaHei"/>
               </a:rPr>
-              <a:t>2. 基于经验制定活动主题、内容方向和触达策略</a:t>
+              <a:t>2. 基于人工经验制定会员分层策略、营销主题和活动方向</a:t>
             </a:r>
           </a:p>
           <a:p>
@@ -5792,7 +5792,7 @@
                 </a:solidFill>
                 <a:latin typeface="Microsoft YaHei"/>
               </a:rPr>
-              <a:t>3. 人工生成营销文案、活动配图和页面内容，并反复协调修改</a:t>
+              <a:t>3. 分别组织文案、配图和活动页面内容，跨团队反复协调修改</a:t>
             </a:r>
           </a:p>
           <a:p>
@@ -5808,7 +5808,7 @@
                 </a:solidFill>
                 <a:latin typeface="Microsoft YaHei"/>
               </a:rPr>
-              <a:t>4. 活动上线后再人工汇总经营数据做效果复盘</a:t>
+              <a:t>4. 活动上线后再人工整理数据做效果复盘与客群分析</a:t>
             </a:r>
           </a:p>
         </p:txBody>
@@ -5933,7 +5933,7 @@
                 </a:solidFill>
                 <a:latin typeface="Microsoft YaHei"/>
               </a:rPr>
-              <a:t>1. 会员洞察、内容生产和活动执行链路长，经营响应速度慢</a:t>
+              <a:t>1. 会员分层、内容生产和活动执行分散在多个系统与团队中，准备周期长</a:t>
             </a:r>
           </a:p>
           <a:p>
@@ -5949,7 +5949,7 @@
                 </a:solidFill>
                 <a:latin typeface="Microsoft YaHei"/>
               </a:rPr>
-              <a:t>2. 活动落地依赖多人协同与人工反复修改，内容生产效率低</a:t>
+              <a:t>2. 活动复盘和洞察回流速度慢，难以及时指导下一轮会员运营动作</a:t>
             </a:r>
           </a:p>
           <a:p>
@@ -5965,7 +5965,7 @@
                 </a:solidFill>
                 <a:latin typeface="Microsoft YaHei"/>
               </a:rPr>
-              <a:t>3. 流失预警与保留动作滞后，复盘结果难以及时回流到下一轮运营</a:t>
+              <a:t>3. 流失预警不及时，高风险会员干预常常发生在价值已经下滑之后</a:t>
             </a:r>
           </a:p>
         </p:txBody>
@@ -6049,7 +6049,7 @@
                 </a:solidFill>
                 <a:latin typeface="Microsoft YaHei"/>
               </a:rPr>
-              <a:t>优先切口：会员洞察、内容生产和活动执行链路长，经营响应速度慢</a:t>
+              <a:t>优先切口：会员分层、内容生产和活动执行分散在多个系统与团队中，准备周期长</a:t>
             </a:r>
           </a:p>
         </p:txBody>
@@ -6325,7 +6325,7 @@
                 </a:solidFill>
                 <a:latin typeface="Microsoft YaHei"/>
               </a:rPr>
-              <a:t>对跨界电商会员运营来说，最值得优先验证的机会是把客户洞察、内容生成和保留动作收敛到一个统一工作台中，直接提升增长与留存效率。</a:t>
+              <a:t>对跨界电商会员运营来说，优先验证一个把客户洞察、内容生成和保留动作串起来的 AI 增长闭环，是最容易落地且最能体现业务价值的切入口。</a:t>
             </a:r>
           </a:p>
         </p:txBody>
@@ -6450,7 +6450,7 @@
                 </a:solidFill>
                 <a:latin typeface="Microsoft YaHei"/>
               </a:rPr>
-              <a:t>会员数据、活动数据和内容资产已经具备数字化基础，但关键判断和执行仍依赖人工串联，正适合用 AI 先跑通一条高价值闭环。</a:t>
+              <a:t>会员数据、活动数据和内容生产需求已经在线化，但从洞察到执行仍依赖人工衔接，适合现在通过工作台形态快速验证 AI 的联动价值。</a:t>
             </a:r>
           </a:p>
         </p:txBody>
@@ -6575,7 +6575,7 @@
                 </a:solidFill>
                 <a:latin typeface="Microsoft YaHei"/>
               </a:rPr>
-              <a:t>会员分层和重点客群识别分散在多个系统中，运营团队难以快速形成一致判断</a:t>
+              <a:t>会员生命周期运营涉及分层、内容、活动和保留多个环节，当前协同链路长且响应慢</a:t>
             </a:r>
           </a:p>
         </p:txBody>
@@ -8097,7 +8097,7 @@
                 </a:solidFill>
                 <a:latin typeface="Microsoft YaHei"/>
               </a:rPr>
-              <a:t>会员运营团队准备发起新一轮面向重点客群的增长活动</a:t>
+              <a:t>会员运营团队准备针对重点会员客群发起新一轮增长活动或保留动作</a:t>
             </a:r>
           </a:p>
         </p:txBody>
@@ -8353,7 +8353,7 @@
                 </a:solidFill>
                 <a:latin typeface="Microsoft YaHei"/>
               </a:rPr>
-              <a:t>1. 系统读取会员画像、活动结果、渠道反馈和生命周期行为数据</a:t>
+              <a:t>1. 系统读取会员画像、历史活动结果、渠道反馈和行为数据</a:t>
             </a:r>
           </a:p>
         </p:txBody>
@@ -8566,7 +8566,7 @@
                 </a:solidFill>
                 <a:latin typeface="Microsoft YaHei"/>
               </a:rPr>
-              <a:t>2. AI 识别高价值会员、潜在流失会员和本轮活动机会点</a:t>
+              <a:t>2. AI 识别高价值会员客群、潜在流失会员和可优先推进的运营机会</a:t>
             </a:r>
           </a:p>
         </p:txBody>
@@ -8779,7 +8779,7 @@
                 </a:solidFill>
                 <a:latin typeface="Microsoft YaHei"/>
               </a:rPr>
-              <a:t>3. AI 自动生成营销文案、活动配图和页面草稿</a:t>
+              <a:t>3. AI 生成个性化营销文案、活动配图和页面草稿，辅助快速完成活动准备</a:t>
             </a:r>
           </a:p>
         </p:txBody>
@@ -8992,7 +8992,7 @@
                 </a:solidFill>
                 <a:latin typeface="Microsoft YaHei"/>
               </a:rPr>
-              <a:t>4. 系统汇总活动表现并输出复盘分析与下一轮优化建议</a:t>
+              <a:t>4. 系统汇总活动效果并输出复盘分析，识别下一轮优化方向</a:t>
             </a:r>
           </a:p>
         </p:txBody>
@@ -9205,7 +9205,7 @@
                 </a:solidFill>
                 <a:latin typeface="Microsoft YaHei"/>
               </a:rPr>
-              <a:t>5. 针对高流失风险会员触发保留建议和重点跟进动作</a:t>
+              <a:t>5. 针对高流失风险会员生成保留建议和跟进动作，推动运营闭环</a:t>
             </a:r>
           </a:p>
         </p:txBody>
@@ -9328,7 +9328,7 @@
                 </a:solidFill>
                 <a:latin typeface="Microsoft YaHei"/>
               </a:rPr>
-              <a:t>形成从客户洞察、内容生成、活动执行、效果复盘到流失干预的会员增长闭环</a:t>
+              <a:t>形成从会员洞察、内容生成、活动执行、效果复盘到流失干预的一体化增长闭环</a:t>
             </a:r>
           </a:p>
         </p:txBody>
@@ -9563,7 +9563,7 @@
                 </a:solidFill>
                 <a:latin typeface="Microsoft YaHei"/>
               </a:rPr>
-              <a:t>闭环目标：形成从客户洞察、内容生成、活动执行、效果复盘到流失干预的会员增长闭环</a:t>
+              <a:t>闭环目标：形成从会员洞察、内容生成、活动执行、效果复盘到流失干预的一体化增长闭环</a:t>
             </a:r>
           </a:p>
         </p:txBody>
@@ -11197,7 +11197,7 @@
                 </a:solidFill>
                 <a:latin typeface="Microsoft YaHei"/>
               </a:rPr>
-              <a:t>会员画像与客群洞察 -&gt; Dynamics 365 Customer Insights, Microsoft Fabric | 交付：会员分层、生命周期洞察与重点客群识别</a:t>
+              <a:t>会员画像整合与客群分层 -&gt; Dynamics 365 Customer Insights, Microsoft Fabric | 交付：会员生命周期洞察、客群识别与运营机会分析</a:t>
             </a:r>
           </a:p>
           <a:p>
@@ -11213,7 +11213,7 @@
                 </a:solidFill>
                 <a:latin typeface="Microsoft YaHei"/>
               </a:rPr>
-              <a:t>营销内容、配图与活动页面生成 -&gt; Azure OpenAI, Azure AI Foundry, Power Pages | 交付：文案生成、视觉素材生成与活动页面原型</a:t>
+              <a:t>营销文案、配图与活动页面生成 -&gt; Azure OpenAI, Azure AI Foundry, Power Pages | 交付：个性化营销内容、活动配图和落地页原型</a:t>
             </a:r>
           </a:p>
           <a:p>
@@ -11229,7 +11229,7 @@
                 </a:solidFill>
                 <a:latin typeface="Microsoft YaHei"/>
               </a:rPr>
-              <a:t>活动复盘与流失预警联动 -&gt; Microsoft Fabric, Power BI, Power Automate | 交付：经营分析、风险预警与后续保留动作建议</a:t>
+              <a:t>活动复盘与流失预警联动 -&gt; Microsoft Fabric, Power BI, Power Automate | 交付：活动效果分析、风险预警与保留动作编排</a:t>
             </a:r>
           </a:p>
         </p:txBody>
@@ -11477,7 +11477,7 @@
                 </a:solidFill>
                 <a:latin typeface="Microsoft YaHei"/>
               </a:rPr>
-              <a:t>现场交付物：Workshop 定制化方案 PPT / 会员增长与保留运营工作台原型建议 / POC 验证范围与里程碑建议</a:t>
+              <a:t>现场交付物：方案 PPT / 会员增长与保留运营工作台原型建议 / POC 验证范围与实施路径</a:t>
             </a:r>
           </a:p>
         </p:txBody>
@@ -11753,7 +11753,7 @@
                 </a:solidFill>
                 <a:latin typeface="Microsoft YaHei"/>
               </a:rPr>
-              <a:t>缩短从会员洞察到活动上线的准备周期</a:t>
+              <a:t>缩短会员运营从洞察到活动上线的准备周期</a:t>
             </a:r>
           </a:p>
           <a:p>
@@ -11769,7 +11769,7 @@
                 </a:solidFill>
                 <a:latin typeface="Microsoft YaHei"/>
               </a:rPr>
-              <a:t>提升营销内容、页面和素材的生产效率</a:t>
+              <a:t>提升营销内容、配图和活动页面的生产效率</a:t>
             </a:r>
           </a:p>
           <a:p>
@@ -11785,7 +11785,7 @@
                 </a:solidFill>
                 <a:latin typeface="Microsoft YaHei"/>
               </a:rPr>
-              <a:t>让活动复盘结果更快回流到下一轮增长动作</a:t>
+              <a:t>让活动复盘结果更快回流到下一轮会员增长动作</a:t>
             </a:r>
           </a:p>
           <a:p>
@@ -11926,7 +11926,7 @@
                 </a:solidFill>
                 <a:latin typeface="Microsoft YaHei"/>
               </a:rPr>
-              <a:t>活动准备周期缩短 40%</a:t>
+              <a:t>会员运营活动准备周期缩短 40%</a:t>
             </a:r>
           </a:p>
           <a:p>
@@ -11942,7 +11942,7 @@
                 </a:solidFill>
                 <a:latin typeface="Microsoft YaHei"/>
               </a:rPr>
-              <a:t>营销内容生产效率提升 50%</a:t>
+              <a:t>营销内容与页面生产效率提升 50%</a:t>
             </a:r>
           </a:p>
           <a:p>
@@ -11974,7 +11974,7 @@
                 </a:solidFill>
                 <a:latin typeface="Microsoft YaHei"/>
               </a:rPr>
-              <a:t>高流失风险会员识别准确率达到 80%</a:t>
+              <a:t>高流失会员识别准确率达到 80%</a:t>
             </a:r>
           </a:p>
         </p:txBody>
@@ -12099,7 +12099,7 @@
                 </a:solidFill>
                 <a:latin typeface="Microsoft YaHei"/>
               </a:rPr>
-              <a:t>1. 会员分层和流失判断的业务可解释性</a:t>
+              <a:t>1. 会员分层与流失判断的业务可解释性</a:t>
             </a:r>
           </a:p>
           <a:p>
@@ -12131,7 +12131,7 @@
                 </a:solidFill>
                 <a:latin typeface="Microsoft YaHei"/>
               </a:rPr>
-              <a:t>3. 活动复盘结果对下一轮运营动作的指导价值</a:t>
+              <a:t>3. 活动复盘结果对下一轮运营策略的指导价值</a:t>
             </a:r>
           </a:p>
         </p:txBody>
@@ -12423,7 +12423,7 @@
                 </a:solidFill>
                 <a:latin typeface="Microsoft YaHei"/>
               </a:rPr>
-              <a:t>会员增长与保留运营工作台；目标：把会员洞察、营销内容生成、活动复盘和保留动作集中到一个可操作的工作台中</a:t>
+              <a:t>会员增长与保留运营工作台；目标：把会员洞察、营销内容生成、活动落地、效果复盘和流失干预集中到一个可操作的工作台中</a:t>
             </a:r>
           </a:p>
           <a:p>
@@ -12737,7 +12737,7 @@
                 </a:solidFill>
                 <a:latin typeface="Microsoft YaHei"/>
               </a:rPr>
-              <a:t>1. 确认一个重点会员客群和一类核心营销活动作为试点</a:t>
+              <a:t>1. 确认一个重点会员客群和一类典型活动作为试点</a:t>
             </a:r>
           </a:p>
           <a:p>
@@ -12753,7 +12753,7 @@
                 </a:solidFill>
                 <a:latin typeface="Microsoft YaHei"/>
               </a:rPr>
-              <a:t>2. 准备会员画像、历史活动结果和流失样本数据</a:t>
+              <a:t>2. 准备会员画像、活动结果和高流失会员样本数据</a:t>
             </a:r>
           </a:p>
           <a:p>
@@ -12769,7 +12769,7 @@
                 </a:solidFill>
                 <a:latin typeface="Microsoft YaHei"/>
               </a:rPr>
-              <a:t>3. 两周内完成工作台演示原型与验证口径</a:t>
+              <a:t>3. 两周内完成工作台原型与验证口径</a:t>
             </a:r>
           </a:p>
           <a:p>

</xml_diff>